<commit_message>
cosmetic edits mainly, one new plot
</commit_message>
<xml_diff>
--- a/bike_nyc_gis.pptx
+++ b/bike_nyc_gis.pptx
@@ -7390,42 +7390,6 @@
       </p:graphicFrame>
       <p:pic>
         <p:nvPicPr>
-          <p:cNvPr id="19" name="Picture 18" descr="A graph of a bicycle lane&#10;&#10;AI-generated content may be incorrect.">
-            <a:extLst>
-              <a:ext uri="{FF2B5EF4-FFF2-40B4-BE49-F238E27FC236}">
-                <a16:creationId xmlns:a16="http://schemas.microsoft.com/office/drawing/2014/main" id="{D79AC920-7F12-1ABA-9801-826C8C2859F9}"/>
-              </a:ext>
-            </a:extLst>
-          </p:cNvPr>
-          <p:cNvPicPr>
-            <a:picLocks noChangeAspect="1"/>
-          </p:cNvPicPr>
-          <p:nvPr/>
-        </p:nvPicPr>
-        <p:blipFill>
-          <a:blip r:embed="rId2">
-            <a:extLst>
-              <a:ext uri="{28A0092B-C50C-407E-A947-70E740481C1C}">
-                <a14:useLocalDpi xmlns:a14="http://schemas.microsoft.com/office/drawing/2010/main" val="0"/>
-              </a:ext>
-            </a:extLst>
-          </a:blip>
-          <a:stretch>
-            <a:fillRect/>
-          </a:stretch>
-        </p:blipFill>
-        <p:spPr>
-          <a:xfrm>
-            <a:off x="1024620" y="19573021"/>
-            <a:ext cx="9925048" cy="4962524"/>
-          </a:xfrm>
-          <a:prstGeom prst="rect">
-            <a:avLst/>
-          </a:prstGeom>
-        </p:spPr>
-      </p:pic>
-      <p:pic>
-        <p:nvPicPr>
           <p:cNvPr id="23" name="Picture 22" descr="A map of a city with different colored circles&#10;&#10;AI-generated content may be incorrect.">
             <a:extLst>
               <a:ext uri="{FF2B5EF4-FFF2-40B4-BE49-F238E27FC236}">
@@ -7439,7 +7403,7 @@
           <p:nvPr/>
         </p:nvPicPr>
         <p:blipFill>
-          <a:blip r:embed="rId3">
+          <a:blip r:embed="rId2">
             <a:extLst>
               <a:ext uri="{28A0092B-C50C-407E-A947-70E740481C1C}">
                 <a14:useLocalDpi xmlns:a14="http://schemas.microsoft.com/office/drawing/2010/main" val="0"/>
@@ -7463,10 +7427,46 @@
       </p:pic>
       <p:pic>
         <p:nvPicPr>
-          <p:cNvPr id="39" name="Picture 38" descr="A map of the united states&#10;&#10;AI-generated content may be incorrect.">
+          <p:cNvPr id="8" name="Picture 7" descr="A graph showing a number of lanes&#10;&#10;AI-generated content may be incorrect.">
             <a:extLst>
               <a:ext uri="{FF2B5EF4-FFF2-40B4-BE49-F238E27FC236}">
-                <a16:creationId xmlns:a16="http://schemas.microsoft.com/office/drawing/2014/main" id="{63DE17D0-CB84-B4D9-2B8F-CD2CD5AE7632}"/>
+                <a16:creationId xmlns:a16="http://schemas.microsoft.com/office/drawing/2014/main" id="{1FEAA516-6BF9-E546-FC05-317B2015DB59}"/>
+              </a:ext>
+            </a:extLst>
+          </p:cNvPr>
+          <p:cNvPicPr>
+            <a:picLocks noChangeAspect="1"/>
+          </p:cNvPicPr>
+          <p:nvPr/>
+        </p:nvPicPr>
+        <p:blipFill>
+          <a:blip r:embed="rId3">
+            <a:extLst>
+              <a:ext uri="{28A0092B-C50C-407E-A947-70E740481C1C}">
+                <a14:useLocalDpi xmlns:a14="http://schemas.microsoft.com/office/drawing/2010/main" val="0"/>
+              </a:ext>
+            </a:extLst>
+          </a:blip>
+          <a:stretch>
+            <a:fillRect/>
+          </a:stretch>
+        </p:blipFill>
+        <p:spPr>
+          <a:xfrm>
+            <a:off x="1140824" y="18218474"/>
+            <a:ext cx="10599631" cy="7419742"/>
+          </a:xfrm>
+          <a:prstGeom prst="rect">
+            <a:avLst/>
+          </a:prstGeom>
+        </p:spPr>
+      </p:pic>
+      <p:pic>
+        <p:nvPicPr>
+          <p:cNvPr id="11" name="Picture 10" descr="A map of the united kingdom&#10;&#10;AI-generated content may be incorrect.">
+            <a:extLst>
+              <a:ext uri="{FF2B5EF4-FFF2-40B4-BE49-F238E27FC236}">
+                <a16:creationId xmlns:a16="http://schemas.microsoft.com/office/drawing/2014/main" id="{B66B0A67-6369-AF30-7ACC-BB407ED047DB}"/>
               </a:ext>
             </a:extLst>
           </p:cNvPr>
@@ -7489,44 +7489,8 @@
         </p:blipFill>
         <p:spPr>
           <a:xfrm>
-            <a:off x="10231873" y="19087524"/>
-            <a:ext cx="11831746" cy="9859788"/>
-          </a:xfrm>
-          <a:prstGeom prst="rect">
-            <a:avLst/>
-          </a:prstGeom>
-        </p:spPr>
-      </p:pic>
-      <p:pic>
-        <p:nvPicPr>
-          <p:cNvPr id="41" name="Picture 40" descr="A map of the united states&#10;&#10;AI-generated content may be incorrect.">
-            <a:extLst>
-              <a:ext uri="{FF2B5EF4-FFF2-40B4-BE49-F238E27FC236}">
-                <a16:creationId xmlns:a16="http://schemas.microsoft.com/office/drawing/2014/main" id="{B11BE36D-3BA8-FB7D-67B5-E5A2EE80FC48}"/>
-              </a:ext>
-            </a:extLst>
-          </p:cNvPr>
-          <p:cNvPicPr>
-            <a:picLocks noChangeAspect="1"/>
-          </p:cNvPicPr>
-          <p:nvPr/>
-        </p:nvPicPr>
-        <p:blipFill>
-          <a:blip r:embed="rId5">
-            <a:extLst>
-              <a:ext uri="{28A0092B-C50C-407E-A947-70E740481C1C}">
-                <a14:useLocalDpi xmlns:a14="http://schemas.microsoft.com/office/drawing/2010/main" val="0"/>
-              </a:ext>
-            </a:extLst>
-          </a:blip>
-          <a:stretch>
-            <a:fillRect/>
-          </a:stretch>
-        </p:blipFill>
-        <p:spPr>
-          <a:xfrm>
-            <a:off x="11270946" y="8829532"/>
-            <a:ext cx="10000680" cy="10000680"/>
+            <a:off x="11245481" y="9841117"/>
+            <a:ext cx="9394491" cy="9394491"/>
           </a:xfrm>
           <a:prstGeom prst="rect">
             <a:avLst/>

</xml_diff>

<commit_message>
finalizing analysis a bit more
</commit_message>
<xml_diff>
--- a/bike_nyc_gis.pptx
+++ b/bike_nyc_gis.pptx
@@ -226,7 +226,7 @@
           <a:p>
             <a:fld id="{932B582C-2CC0-4B80-AE07-643F9FF6B0D2}" type="datetimeFigureOut">
               <a:rPr lang="en-US" smtClean="0"/>
-              <a:t>11/16/25</a:t>
+              <a:t>11/17/25</a:t>
             </a:fld>
             <a:endParaRPr lang="en-US"/>
           </a:p>
@@ -403,7 +403,7 @@
           <a:p>
             <a:fld id="{06FF3B7B-C834-4806-85FF-593E379045A3}" type="datetimeFigureOut">
               <a:rPr lang="en-US" smtClean="0"/>
-              <a:t>11/16/25</a:t>
+              <a:t>11/17/25</a:t>
             </a:fld>
             <a:endParaRPr lang="en-US"/>
           </a:p>
@@ -817,7 +817,7 @@
           <a:p>
             <a:fld id="{985D6BDF-9D0E-4E2B-85B8-D8F4790360C9}" type="datetimeFigureOut">
               <a:rPr lang="en-US" smtClean="0"/>
-              <a:t>11/16/25</a:t>
+              <a:t>11/17/25</a:t>
             </a:fld>
             <a:endParaRPr lang="en-US" dirty="0"/>
           </a:p>
@@ -1015,7 +1015,7 @@
           <a:p>
             <a:fld id="{985D6BDF-9D0E-4E2B-85B8-D8F4790360C9}" type="datetimeFigureOut">
               <a:rPr lang="en-US" smtClean="0"/>
-              <a:t>11/16/25</a:t>
+              <a:t>11/17/25</a:t>
             </a:fld>
             <a:endParaRPr lang="en-US" dirty="0"/>
           </a:p>
@@ -1223,7 +1223,7 @@
           <a:p>
             <a:fld id="{985D6BDF-9D0E-4E2B-85B8-D8F4790360C9}" type="datetimeFigureOut">
               <a:rPr lang="en-US" smtClean="0"/>
-              <a:t>11/16/25</a:t>
+              <a:t>11/17/25</a:t>
             </a:fld>
             <a:endParaRPr lang="en-US" dirty="0"/>
           </a:p>
@@ -1676,7 +1676,7 @@
           <a:p>
             <a:fld id="{985D6BDF-9D0E-4E2B-85B8-D8F4790360C9}" type="datetimeFigureOut">
               <a:rPr lang="en-US" smtClean="0"/>
-              <a:t>11/16/25</a:t>
+              <a:t>11/17/25</a:t>
             </a:fld>
             <a:endParaRPr lang="en-US" dirty="0"/>
           </a:p>
@@ -1951,7 +1951,7 @@
           <a:p>
             <a:fld id="{985D6BDF-9D0E-4E2B-85B8-D8F4790360C9}" type="datetimeFigureOut">
               <a:rPr lang="en-US" smtClean="0"/>
-              <a:t>11/16/25</a:t>
+              <a:t>11/17/25</a:t>
             </a:fld>
             <a:endParaRPr lang="en-US" dirty="0"/>
           </a:p>
@@ -2216,7 +2216,7 @@
           <a:p>
             <a:fld id="{985D6BDF-9D0E-4E2B-85B8-D8F4790360C9}" type="datetimeFigureOut">
               <a:rPr lang="en-US" smtClean="0"/>
-              <a:t>11/16/25</a:t>
+              <a:t>11/17/25</a:t>
             </a:fld>
             <a:endParaRPr lang="en-US" dirty="0"/>
           </a:p>
@@ -2628,7 +2628,7 @@
           <a:p>
             <a:fld id="{985D6BDF-9D0E-4E2B-85B8-D8F4790360C9}" type="datetimeFigureOut">
               <a:rPr lang="en-US" smtClean="0"/>
-              <a:t>11/16/25</a:t>
+              <a:t>11/17/25</a:t>
             </a:fld>
             <a:endParaRPr lang="en-US" dirty="0"/>
           </a:p>
@@ -2769,7 +2769,7 @@
           <a:p>
             <a:fld id="{985D6BDF-9D0E-4E2B-85B8-D8F4790360C9}" type="datetimeFigureOut">
               <a:rPr lang="en-US" smtClean="0"/>
-              <a:t>11/16/25</a:t>
+              <a:t>11/17/25</a:t>
             </a:fld>
             <a:endParaRPr lang="en-US" dirty="0"/>
           </a:p>
@@ -2882,7 +2882,7 @@
           <a:p>
             <a:fld id="{985D6BDF-9D0E-4E2B-85B8-D8F4790360C9}" type="datetimeFigureOut">
               <a:rPr lang="en-US" smtClean="0"/>
-              <a:t>11/16/25</a:t>
+              <a:t>11/17/25</a:t>
             </a:fld>
             <a:endParaRPr lang="en-US" dirty="0"/>
           </a:p>
@@ -3193,7 +3193,7 @@
           <a:p>
             <a:fld id="{985D6BDF-9D0E-4E2B-85B8-D8F4790360C9}" type="datetimeFigureOut">
               <a:rPr lang="en-US" smtClean="0"/>
-              <a:t>11/16/25</a:t>
+              <a:t>11/17/25</a:t>
             </a:fld>
             <a:endParaRPr lang="en-US" dirty="0"/>
           </a:p>
@@ -3481,7 +3481,7 @@
           <a:p>
             <a:fld id="{985D6BDF-9D0E-4E2B-85B8-D8F4790360C9}" type="datetimeFigureOut">
               <a:rPr lang="en-US" smtClean="0"/>
-              <a:t>11/16/25</a:t>
+              <a:t>11/17/25</a:t>
             </a:fld>
             <a:endParaRPr lang="en-US" dirty="0"/>
           </a:p>
@@ -3722,7 +3722,7 @@
           <a:p>
             <a:fld id="{985D6BDF-9D0E-4E2B-85B8-D8F4790360C9}" type="datetimeFigureOut">
               <a:rPr lang="en-US" smtClean="0"/>
-              <a:t>11/16/25</a:t>
+              <a:t>11/17/25</a:t>
             </a:fld>
             <a:endParaRPr lang="en-US" dirty="0"/>
           </a:p>
@@ -4140,6 +4140,42 @@
           <a:chExt cx="0" cy="0"/>
         </a:xfrm>
       </p:grpSpPr>
+      <p:pic>
+        <p:nvPicPr>
+          <p:cNvPr id="19" name="Picture 18" descr="A map of the united states&#10;&#10;AI-generated content may be incorrect.">
+            <a:extLst>
+              <a:ext uri="{FF2B5EF4-FFF2-40B4-BE49-F238E27FC236}">
+                <a16:creationId xmlns:a16="http://schemas.microsoft.com/office/drawing/2014/main" id="{1A71817A-50AC-0C47-79D8-BAD26C48C26E}"/>
+              </a:ext>
+            </a:extLst>
+          </p:cNvPr>
+          <p:cNvPicPr>
+            <a:picLocks noChangeAspect="1"/>
+          </p:cNvPicPr>
+          <p:nvPr/>
+        </p:nvPicPr>
+        <p:blipFill>
+          <a:blip r:embed="rId2">
+            <a:extLst>
+              <a:ext uri="{28A0092B-C50C-407E-A947-70E740481C1C}">
+                <a14:useLocalDpi xmlns:a14="http://schemas.microsoft.com/office/drawing/2010/main" val="0"/>
+              </a:ext>
+            </a:extLst>
+          </a:blip>
+          <a:stretch>
+            <a:fillRect/>
+          </a:stretch>
+        </p:blipFill>
+        <p:spPr>
+          <a:xfrm>
+            <a:off x="1066543" y="21539455"/>
+            <a:ext cx="13563857" cy="4521286"/>
+          </a:xfrm>
+          <a:prstGeom prst="rect">
+            <a:avLst/>
+          </a:prstGeom>
+        </p:spPr>
+      </p:pic>
       <p:sp>
         <p:nvSpPr>
           <p:cNvPr id="4" name="Text Box 122"/>
@@ -4509,7 +4545,7 @@
         <p:spPr>
           <a:xfrm>
             <a:off x="631415" y="29857829"/>
-            <a:ext cx="3037217" cy="2223674"/>
+            <a:ext cx="7871298" cy="1361899"/>
           </a:xfrm>
           <a:prstGeom prst="rect">
             <a:avLst/>
@@ -4529,31 +4565,19 @@
           <a:p>
             <a:r>
               <a:rPr lang="en-US" sz="2800" dirty="0"/>
-              <a:t>&lt;your name&gt;</a:t>
+              <a:t>Ravi Brenner</a:t>
             </a:r>
           </a:p>
           <a:p>
             <a:r>
               <a:rPr lang="en-US" sz="2800" dirty="0"/>
-              <a:t>&lt;your organization&gt;</a:t>
+              <a:t>Columbia University Mailman School of Public Health</a:t>
             </a:r>
           </a:p>
           <a:p>
             <a:r>
               <a:rPr lang="en-US" sz="2800" dirty="0"/>
-              <a:t>Email:</a:t>
-            </a:r>
-          </a:p>
-          <a:p>
-            <a:r>
-              <a:rPr lang="en-US" sz="2800" dirty="0"/>
-              <a:t>Website:</a:t>
-            </a:r>
-          </a:p>
-          <a:p>
-            <a:r>
-              <a:rPr lang="en-US" sz="2800" dirty="0"/>
-              <a:t>Phone:</a:t>
+              <a:t>Email: irb2118@cumc.columbia.edu</a:t>
             </a:r>
           </a:p>
         </p:txBody>
@@ -4595,8 +4619,8 @@
         </p:nvSpPr>
         <p:spPr>
           <a:xfrm>
-            <a:off x="11316666" y="29892848"/>
-            <a:ext cx="14630400" cy="2194560"/>
+            <a:off x="11316666" y="29892847"/>
+            <a:ext cx="10247934" cy="2888239"/>
           </a:xfrm>
           <a:prstGeom prst="rect">
             <a:avLst/>
@@ -4615,8 +4639,23 @@
             </a:pPr>
             <a:r>
               <a:rPr lang="en-US" sz="1400" dirty="0"/>
-              <a:t> </a:t>
-            </a:r>
+              <a:t> Wall SP, Lee DC, Frangos SG, et al. The Effect of Sharrows, Painted Bicycle Lanes and Physically Protected Paths on the Severity of Bicycle Injuries Caused by Motor Vehicles. </a:t>
+            </a:r>
+            <a:r>
+              <a:rPr lang="en-US" sz="1400" i="1" dirty="0"/>
+              <a:t>Safety (Basel)</a:t>
+            </a:r>
+            <a:r>
+              <a:rPr lang="en-US" sz="1400" dirty="0"/>
+              <a:t>. 2016;2(4):26. doi:</a:t>
+            </a:r>
+            <a:r>
+              <a:rPr lang="en-US" sz="1400" dirty="0">
+                <a:hlinkClick r:id="rId3"/>
+              </a:rPr>
+              <a:t>10.3390/safety2040026</a:t>
+            </a:r>
+            <a:endParaRPr lang="en-US" sz="1400" dirty="0"/>
           </a:p>
           <a:p>
             <a:pPr marL="342842" indent="-342842">
@@ -4625,8 +4664,31 @@
             </a:pPr>
             <a:r>
               <a:rPr lang="en-US" sz="1400" dirty="0"/>
-              <a:t> </a:t>
-            </a:r>
+              <a:t> Garber MD, Watkins KE, Flanders WD, et al. Bicycle infrastructure and the incidence rate of crashes with cars: A case-control study with Strava data in Atlanta. </a:t>
+            </a:r>
+            <a:r>
+              <a:rPr lang="en-US" sz="1400" i="1" dirty="0"/>
+              <a:t>J </a:t>
+            </a:r>
+            <a:r>
+              <a:rPr lang="en-US" sz="1400" i="1" dirty="0" err="1"/>
+              <a:t>Transp</a:t>
+            </a:r>
+            <a:r>
+              <a:rPr lang="en-US" sz="1400" i="1" dirty="0"/>
+              <a:t> Health</a:t>
+            </a:r>
+            <a:r>
+              <a:rPr lang="en-US" sz="1400" dirty="0"/>
+              <a:t>. 2023;32:101669. doi:</a:t>
+            </a:r>
+            <a:r>
+              <a:rPr lang="en-US" sz="1400" dirty="0">
+                <a:hlinkClick r:id="rId4"/>
+              </a:rPr>
+              <a:t>10.1016/j.jth.2023.101669</a:t>
+            </a:r>
+            <a:endParaRPr lang="en-US" sz="1400" dirty="0"/>
           </a:p>
           <a:p>
             <a:pPr marL="342842" indent="-342842">
@@ -4635,8 +4697,23 @@
             </a:pPr>
             <a:r>
               <a:rPr lang="en-US" sz="1400" dirty="0"/>
-              <a:t> </a:t>
-            </a:r>
+              <a:t> Chen L, Chen C, Srinivasan R, McKnight CE, Ewing R, Roe M. Evaluating the safety effects of bicycle lanes in New York City. </a:t>
+            </a:r>
+            <a:r>
+              <a:rPr lang="en-US" sz="1400" i="1" dirty="0"/>
+              <a:t>Am J Public Health</a:t>
+            </a:r>
+            <a:r>
+              <a:rPr lang="en-US" sz="1400" dirty="0"/>
+              <a:t>. 2012;102(6):1120-1127. doi:</a:t>
+            </a:r>
+            <a:r>
+              <a:rPr lang="en-US" sz="1400" dirty="0">
+                <a:hlinkClick r:id="rId5"/>
+              </a:rPr>
+              <a:t>10.2105/AJPH.2011.300319</a:t>
+            </a:r>
+            <a:endParaRPr lang="en-US" sz="1400" dirty="0"/>
           </a:p>
           <a:p>
             <a:pPr marL="342842" indent="-342842">
@@ -4645,8 +4722,15 @@
             </a:pPr>
             <a:r>
               <a:rPr lang="en-US" sz="1400" dirty="0"/>
-              <a:t> </a:t>
-            </a:r>
+              <a:t>NYC Open Data. Community Districts. Accessed November 17, 2025. </a:t>
+            </a:r>
+            <a:r>
+              <a:rPr lang="en-US" sz="1400" u="sng" dirty="0">
+                <a:hlinkClick r:id="rId6"/>
+              </a:rPr>
+              <a:t>https://data.cityofnewyork.us/City-Government/Community-Districts/5crt-au7u/about_data</a:t>
+            </a:r>
+            <a:endParaRPr lang="en-US" sz="1400" u="sng" dirty="0"/>
           </a:p>
           <a:p>
             <a:pPr marL="342842" indent="-342842">
@@ -4655,8 +4739,15 @@
             </a:pPr>
             <a:r>
               <a:rPr lang="en-US" sz="1400" dirty="0"/>
-              <a:t> </a:t>
-            </a:r>
+              <a:t>NYC Open Data. Motor Vehicle Collisions - Crashes. Accessed November 17, 2025. </a:t>
+            </a:r>
+            <a:r>
+              <a:rPr lang="en-US" sz="1400" u="sng" dirty="0">
+                <a:hlinkClick r:id="rId7"/>
+              </a:rPr>
+              <a:t>https://data.cityofnewyork.us/Public-Safety/Motor-Vehicle-Collisions-Crashes/h9gi-nx95/about_data</a:t>
+            </a:r>
+            <a:endParaRPr lang="en-US" sz="1400" u="sng" dirty="0"/>
           </a:p>
           <a:p>
             <a:pPr marL="342842" indent="-342842">
@@ -4665,44 +4756,14 @@
             </a:pPr>
             <a:r>
               <a:rPr lang="en-US" sz="1400" dirty="0"/>
-              <a:t> </a:t>
-            </a:r>
-          </a:p>
-          <a:p>
-            <a:pPr marL="342842" indent="-342842">
-              <a:buFont typeface="+mj-lt"/>
-              <a:buAutoNum type="arabicPeriod"/>
-            </a:pPr>
-            <a:r>
-              <a:rPr lang="en-US" sz="1400" dirty="0"/>
-              <a:t> </a:t>
-            </a:r>
-          </a:p>
-          <a:p>
-            <a:pPr marL="342842" indent="-342842">
-              <a:buFont typeface="+mj-lt"/>
-              <a:buAutoNum type="arabicPeriod"/>
-            </a:pPr>
-            <a:r>
-              <a:rPr lang="en-US" sz="1400" dirty="0"/>
-              <a:t> </a:t>
-            </a:r>
-          </a:p>
-          <a:p>
-            <a:pPr marL="342842" indent="-342842">
-              <a:buFont typeface="+mj-lt"/>
-              <a:buAutoNum type="arabicPeriod"/>
-            </a:pPr>
-            <a:r>
-              <a:rPr lang="en-US" sz="1400" dirty="0"/>
-              <a:t> </a:t>
-            </a:r>
-          </a:p>
-          <a:p>
-            <a:pPr marL="342842" indent="-342842">
-              <a:buFont typeface="+mj-lt"/>
-              <a:buAutoNum type="arabicPeriod"/>
-            </a:pPr>
+              <a:t>NYC Open Data. New York City Bike Routes. Accessed November 17, 2025. </a:t>
+            </a:r>
+            <a:r>
+              <a:rPr lang="en-US" sz="1400" u="sng" dirty="0">
+                <a:hlinkClick r:id="rId8"/>
+              </a:rPr>
+              <a:t>https://data.cityofnewyork.us/dataset/New-York-City-Bike-Routes/mzxg-pwib/about_data</a:t>
+            </a:r>
             <a:r>
               <a:rPr lang="en-US" sz="1400" dirty="0"/>
               <a:t>  </a:t>
@@ -4756,8 +4817,8 @@
         </p:nvSpPr>
         <p:spPr bwMode="auto">
           <a:xfrm>
-            <a:off x="1140824" y="5655225"/>
-            <a:ext cx="9692640" cy="2862276"/>
+            <a:off x="1104643" y="5037643"/>
+            <a:ext cx="9692640" cy="7171147"/>
           </a:xfrm>
           <a:prstGeom prst="rect">
             <a:avLst/>
@@ -4877,39 +4938,39 @@
             </a:lvl9pPr>
           </a:lstStyle>
           <a:p>
-            <a:pPr eaLnBrk="1" hangingPunct="1"/>
+            <a:pPr marL="457200" indent="-457200" eaLnBrk="1" hangingPunct="1">
+              <a:buFont typeface="Wingdings" pitchFamily="2" charset="2"/>
+              <a:buChar char="§"/>
+            </a:pPr>
             <a:r>
               <a:rPr lang="en-US" sz="2800" dirty="0">
                 <a:latin typeface="Calibri" pitchFamily="34" charset="0"/>
               </a:rPr>
-              <a:t>Click here to insert your Abstract text. Type it in or copy and paste from your Word document or other source.</a:t>
-            </a:r>
-          </a:p>
-          <a:p>
-            <a:pPr eaLnBrk="1" hangingPunct="1"/>
-            <a:endParaRPr lang="en-US" sz="2800" dirty="0">
-              <a:latin typeface="Calibri" pitchFamily="34" charset="0"/>
-            </a:endParaRPr>
-          </a:p>
-          <a:p>
-            <a:pPr eaLnBrk="1" hangingPunct="1"/>
+              <a:t>Cycling is a popular form of transit in New York City, with thousands of bike trips taking place every day. Previous studies in New York City have found that physically protected bike lanes were associated with 23% fewer injuries, while conventional separate painted lanes reduce injury risk by 90% compared to non-bicycle routes [1]. Other studies have found that conventional bike lanes are associated with a higher incidence of crashes [2]. </a:t>
+            </a:r>
+          </a:p>
+          <a:p>
+            <a:pPr marL="457200" indent="-457200" eaLnBrk="1" hangingPunct="1">
+              <a:buFont typeface="Wingdings" pitchFamily="2" charset="2"/>
+              <a:buChar char="§"/>
+            </a:pPr>
             <a:r>
               <a:rPr lang="en-US" sz="2800" dirty="0">
                 <a:latin typeface="Calibri" pitchFamily="34" charset="0"/>
               </a:rPr>
-              <a:t>This text box will automatically re-size to your text. To turn off that feature, right click inside this box and go to </a:t>
-            </a:r>
-            <a:r>
-              <a:rPr lang="en-US" sz="2800" b="1" dirty="0">
-                <a:latin typeface="Calibri" pitchFamily="34" charset="0"/>
-              </a:rPr>
-              <a:t>Format Shape, Text Box, Autofit</a:t>
-            </a:r>
+              <a:t>Previous studies of bicycle crashes and lanes have found that bicycle-involved crashes may increase following bike lane installation, largely due to an increased traffic volume of cyclists [3]</a:t>
+            </a:r>
+          </a:p>
+          <a:p>
+            <a:pPr marL="457200" indent="-457200" eaLnBrk="1" hangingPunct="1">
+              <a:buFont typeface="Wingdings" pitchFamily="2" charset="2"/>
+              <a:buChar char="§"/>
+            </a:pPr>
             <a:r>
               <a:rPr lang="en-US" sz="2800" dirty="0">
                 <a:latin typeface="Calibri" pitchFamily="34" charset="0"/>
               </a:rPr>
-              <a:t>, and select the “Do Not Autofit” radio button.</a:t>
+              <a:t>This analysis aimed to understand the distribution of bike collisions and bike lanes across community districts in New York City, and to assess if there is any relationship between collisions and the type of bike lane.</a:t>
             </a:r>
           </a:p>
         </p:txBody>
@@ -4922,7 +4983,7 @@
         </p:nvSpPr>
         <p:spPr>
           <a:xfrm>
-            <a:off x="1140824" y="4996410"/>
+            <a:off x="1104643" y="4378828"/>
             <a:ext cx="9692640" cy="685800"/>
           </a:xfrm>
           <a:prstGeom prst="rect">
@@ -4980,7 +5041,7 @@
         </p:nvSpPr>
         <p:spPr bwMode="auto">
           <a:xfrm>
-            <a:off x="11212048" y="5467465"/>
+            <a:off x="1059561" y="12894855"/>
             <a:ext cx="9692640" cy="8032922"/>
           </a:xfrm>
           <a:prstGeom prst="rect">
@@ -5101,108 +5162,75 @@
             </a:lvl9pPr>
           </a:lstStyle>
           <a:p>
-            <a:pPr eaLnBrk="1" hangingPunct="1"/>
+            <a:pPr marL="457200" indent="-457200" eaLnBrk="1" hangingPunct="1">
+              <a:buFont typeface="Wingdings" pitchFamily="2" charset="2"/>
+              <a:buChar char="§"/>
+            </a:pPr>
             <a:r>
               <a:rPr lang="en-US" sz="2800" dirty="0">
                 <a:latin typeface="Calibri" pitchFamily="34" charset="0"/>
               </a:rPr>
-              <a:t>Click here to insert your Results text. Type it in or copy and paste from your Word document or other source.</a:t>
-            </a:r>
-          </a:p>
-          <a:p>
-            <a:pPr eaLnBrk="1" hangingPunct="1"/>
-            <a:endParaRPr lang="en-US" sz="2800" dirty="0">
-              <a:latin typeface="Calibri" pitchFamily="34" charset="0"/>
-            </a:endParaRPr>
-          </a:p>
-          <a:p>
-            <a:pPr eaLnBrk="1" hangingPunct="1"/>
+              <a:t>All data were acquired from NYC Open Data [4-6]. </a:t>
+            </a:r>
+          </a:p>
+          <a:p>
+            <a:pPr marL="457200" indent="-457200" eaLnBrk="1" hangingPunct="1">
+              <a:buFont typeface="Wingdings" pitchFamily="2" charset="2"/>
+              <a:buChar char="§"/>
+            </a:pPr>
             <a:r>
               <a:rPr lang="en-US" sz="2800" dirty="0">
                 <a:latin typeface="Calibri" pitchFamily="34" charset="0"/>
               </a:rPr>
-              <a:t>This text box will automatically re-size to your text. To turn off that feature, right click inside this box and go to </a:t>
-            </a:r>
-            <a:r>
-              <a:rPr lang="en-US" sz="2800" b="1" dirty="0">
-                <a:latin typeface="Calibri" pitchFamily="34" charset="0"/>
-              </a:rPr>
-              <a:t>Format Shape, Text Box, Autofit</a:t>
-            </a:r>
+              <a:t>Each bike collision was assigned to the nearest bike lane within 100 feet of the crash, or no bike lane if there were none within 100 feet. All crashes and bike lane segments were categorized based on the community district in which they fell. Bike lane lengths in miles and community district land areas in square miles were calculated. Bike lane type was determined based on the highest bike lane class available: (1) Protected bike lanes; (2) Conventional bike lanes; (3) shared lanes; (4) Link segments.</a:t>
+            </a:r>
+          </a:p>
+          <a:p>
+            <a:pPr marL="457200" indent="-457200" eaLnBrk="1" hangingPunct="1">
+              <a:buFont typeface="Wingdings" pitchFamily="2" charset="2"/>
+              <a:buChar char="§"/>
+            </a:pPr>
             <a:r>
               <a:rPr lang="en-US" sz="2800" dirty="0">
                 <a:latin typeface="Calibri" pitchFamily="34" charset="0"/>
               </a:rPr>
-              <a:t>, and select the “Do Not Autofit” radio button.</a:t>
-            </a:r>
-          </a:p>
-          <a:p>
-            <a:pPr eaLnBrk="1" hangingPunct="1"/>
-            <a:endParaRPr lang="en-US" sz="2800" dirty="0">
-              <a:latin typeface="Calibri" pitchFamily="34" charset="0"/>
-            </a:endParaRPr>
-          </a:p>
-          <a:p>
-            <a:pPr eaLnBrk="1" hangingPunct="1"/>
+              <a:t>While granular bike traffic data was not available, crash and bike lane density was calculated by dividing the number of crashes or number of bike lanes by the land area of a given community district.</a:t>
+            </a:r>
+          </a:p>
+          <a:p>
+            <a:pPr marL="457200" indent="-457200" eaLnBrk="1" hangingPunct="1">
+              <a:buFont typeface="Wingdings" pitchFamily="2" charset="2"/>
+              <a:buChar char="§"/>
+            </a:pPr>
             <a:r>
               <a:rPr lang="en-US" sz="2800" dirty="0">
                 <a:latin typeface="Calibri" pitchFamily="34" charset="0"/>
               </a:rPr>
-              <a:t>To change the font style of this text box: Click on the border once to highlight the entire text box, then select a different font or font size that suits you. This text is Calibri 28pt and is easily read up to 4 feet away on a 36x36 poster.</a:t>
-            </a:r>
-          </a:p>
-          <a:p>
-            <a:pPr eaLnBrk="1" hangingPunct="1"/>
-            <a:endParaRPr lang="en-US" sz="2800" dirty="0">
-              <a:latin typeface="Calibri" pitchFamily="34" charset="0"/>
-            </a:endParaRPr>
-          </a:p>
-          <a:p>
-            <a:pPr eaLnBrk="1" hangingPunct="1"/>
+              <a:t>R was used for all analyses, including the packages sf and </a:t>
+            </a:r>
+            <a:r>
+              <a:rPr lang="en-US" sz="2800" dirty="0" err="1">
+                <a:latin typeface="Calibri" pitchFamily="34" charset="0"/>
+              </a:rPr>
+              <a:t>biscale</a:t>
+            </a:r>
             <a:r>
               <a:rPr lang="en-US" sz="2800" dirty="0">
                 <a:latin typeface="Calibri" pitchFamily="34" charset="0"/>
               </a:rPr>
-              <a:t>Zoom out to 100% to preview what this will look like on your printed poster.</a:t>
-            </a:r>
-          </a:p>
-          <a:p>
-            <a:pPr eaLnBrk="1" hangingPunct="1"/>
-            <a:endParaRPr lang="en-US" sz="2800" dirty="0">
-              <a:latin typeface="Calibri" pitchFamily="34" charset="0"/>
-            </a:endParaRPr>
-          </a:p>
-          <a:p>
-            <a:pPr eaLnBrk="1" hangingPunct="1"/>
+              <a:t> for spatial analysis. </a:t>
+            </a:r>
+            <a:r>
+              <a:rPr lang="en-US" sz="2800" dirty="0" err="1">
+                <a:latin typeface="Calibri" pitchFamily="34" charset="0"/>
+              </a:rPr>
+              <a:t>Chloropleth</a:t>
+            </a:r>
             <a:r>
               <a:rPr lang="en-US" sz="2800" dirty="0">
                 <a:latin typeface="Calibri" pitchFamily="34" charset="0"/>
               </a:rPr>
-              <a:t>Speaking of Results, yours will look better if you remember to run a spell-check on your poster! After you’ve added your content click on </a:t>
-            </a:r>
-            <a:r>
-              <a:rPr lang="en-US" sz="2800" b="1" dirty="0">
-                <a:latin typeface="Calibri" pitchFamily="34" charset="0"/>
-              </a:rPr>
-              <a:t>Review</a:t>
-            </a:r>
-            <a:r>
-              <a:rPr lang="en-US" sz="2800" dirty="0">
-                <a:latin typeface="Calibri" pitchFamily="34" charset="0"/>
-              </a:rPr>
-              <a:t>, </a:t>
-            </a:r>
-            <a:r>
-              <a:rPr lang="en-US" sz="2800" b="1" dirty="0">
-                <a:latin typeface="Calibri" pitchFamily="34" charset="0"/>
-              </a:rPr>
-              <a:t>Spelling</a:t>
-            </a:r>
-            <a:r>
-              <a:rPr lang="en-US" sz="2800" dirty="0">
-                <a:latin typeface="Calibri" pitchFamily="34" charset="0"/>
-              </a:rPr>
-              <a:t>, or press F7.</a:t>
+              <a:t>, bivariate, and multilayer maps were used, and spatial joins were needed to construct the datasets used in analysis.</a:t>
             </a:r>
           </a:p>
         </p:txBody>
@@ -5217,8 +5245,8 @@
         </p:nvSpPr>
         <p:spPr bwMode="auto">
           <a:xfrm>
-            <a:off x="11316666" y="13341371"/>
-            <a:ext cx="9692640" cy="6309373"/>
+            <a:off x="11316666" y="13276765"/>
+            <a:ext cx="9692640" cy="7602035"/>
           </a:xfrm>
           <a:prstGeom prst="rect">
             <a:avLst/>
@@ -5338,69 +5366,99 @@
             </a:lvl9pPr>
           </a:lstStyle>
           <a:p>
-            <a:pPr eaLnBrk="1" hangingPunct="1"/>
+            <a:pPr marL="457200" indent="-457200" eaLnBrk="1" hangingPunct="1">
+              <a:buFont typeface="Wingdings" pitchFamily="2" charset="2"/>
+              <a:buChar char="§"/>
+            </a:pPr>
             <a:r>
               <a:rPr lang="en-US" sz="2800" dirty="0">
                 <a:latin typeface="Calibri" pitchFamily="34" charset="0"/>
               </a:rPr>
-              <a:t>Click here to insert your Discussion text. Type it in or copy and paste from your Word document or other source.</a:t>
-            </a:r>
-          </a:p>
-          <a:p>
-            <a:pPr eaLnBrk="1" hangingPunct="1"/>
-            <a:endParaRPr lang="en-US" sz="2800" dirty="0">
-              <a:latin typeface="Calibri" pitchFamily="34" charset="0"/>
-            </a:endParaRPr>
-          </a:p>
-          <a:p>
-            <a:pPr eaLnBrk="1" hangingPunct="1"/>
+              <a:t>The amount and types of bike lanes varied substantially by community district (</a:t>
+            </a:r>
+            <a:r>
+              <a:rPr lang="en-US" sz="2800" b="1" dirty="0">
+                <a:latin typeface="Calibri" pitchFamily="34" charset="0"/>
+              </a:rPr>
+              <a:t>Map 1</a:t>
+            </a:r>
             <a:r>
               <a:rPr lang="en-US" sz="2800" dirty="0">
                 <a:latin typeface="Calibri" pitchFamily="34" charset="0"/>
               </a:rPr>
-              <a:t>This text box will automatically re-size to your text. To turn off that feature, right click inside this box and go to </a:t>
+              <a:t>). Protected and conventional lanes comprised most of the mileage (</a:t>
             </a:r>
             <a:r>
               <a:rPr lang="en-US" sz="2800" b="1" dirty="0">
                 <a:latin typeface="Calibri" pitchFamily="34" charset="0"/>
               </a:rPr>
-              <a:t>Format Shape, Text Box, Autofit</a:t>
+              <a:t>Table 1</a:t>
             </a:r>
             <a:r>
               <a:rPr lang="en-US" sz="2800" dirty="0">
                 <a:latin typeface="Calibri" pitchFamily="34" charset="0"/>
               </a:rPr>
-              <a:t>, and select the “Do Not Autofit” radio button.</a:t>
-            </a:r>
-          </a:p>
-          <a:p>
-            <a:pPr eaLnBrk="1" hangingPunct="1"/>
-            <a:endParaRPr lang="en-US" sz="2800" dirty="0">
-              <a:latin typeface="Calibri" pitchFamily="34" charset="0"/>
-            </a:endParaRPr>
-          </a:p>
-          <a:p>
-            <a:pPr eaLnBrk="1" hangingPunct="1"/>
+              <a:t>), although this varied by community district. Many CDs in Manhattan had mostly protected lanes, while many in Brooklyn had more conventional lanes.</a:t>
+            </a:r>
+          </a:p>
+          <a:p>
+            <a:pPr marL="457200" indent="-457200" eaLnBrk="1" hangingPunct="1">
+              <a:buFont typeface="Wingdings" pitchFamily="2" charset="2"/>
+              <a:buChar char="§"/>
+            </a:pPr>
             <a:r>
               <a:rPr lang="en-US" sz="2800" dirty="0">
                 <a:latin typeface="Calibri" pitchFamily="34" charset="0"/>
               </a:rPr>
-              <a:t>To change the font style of this text box: Click on the border once to highlight the entire text box, then select a different font or font size that suits you. This text is Calibri 28pt and is easily read up to 4 feet away on a 36x36 poster.</a:t>
-            </a:r>
-          </a:p>
-          <a:p>
-            <a:pPr eaLnBrk="1" hangingPunct="1"/>
-            <a:endParaRPr lang="en-US" sz="2800" dirty="0">
-              <a:latin typeface="Calibri" pitchFamily="34" charset="0"/>
-            </a:endParaRPr>
-          </a:p>
-          <a:p>
-            <a:pPr eaLnBrk="1" hangingPunct="1"/>
+              <a:t>Crashes per mile were similar in protected and conventional lanes and higher in shared lanes (</a:t>
+            </a:r>
+            <a:r>
+              <a:rPr lang="en-US" sz="2800" b="1" dirty="0">
+                <a:latin typeface="Calibri" pitchFamily="34" charset="0"/>
+              </a:rPr>
+              <a:t>Table 1</a:t>
+            </a:r>
             <a:r>
               <a:rPr lang="en-US" sz="2800" dirty="0">
                 <a:latin typeface="Calibri" pitchFamily="34" charset="0"/>
               </a:rPr>
-              <a:t>Zoom out to 100% to preview what this will look like on your printed poster.</a:t>
+              <a:t>). However, this does not adjust for the possibility that shared lanes are also used more, resulting in more crashes.</a:t>
+            </a:r>
+          </a:p>
+          <a:p>
+            <a:pPr marL="457200" indent="-457200" eaLnBrk="1" hangingPunct="1">
+              <a:buFont typeface="Wingdings" pitchFamily="2" charset="2"/>
+              <a:buChar char="§"/>
+            </a:pPr>
+            <a:r>
+              <a:rPr lang="en-US" sz="2800" dirty="0">
+                <a:latin typeface="Calibri" pitchFamily="34" charset="0"/>
+              </a:rPr>
+              <a:t>Crashes were most dense across Manhattan, as well as parts of Brooklyn and the Bronx, likely reflecting high usage. These areas also have a high density of bike lanes (</a:t>
+            </a:r>
+            <a:r>
+              <a:rPr lang="en-US" sz="2800" b="1" dirty="0">
+                <a:latin typeface="Calibri" pitchFamily="34" charset="0"/>
+              </a:rPr>
+              <a:t>Map 2</a:t>
+            </a:r>
+            <a:r>
+              <a:rPr lang="en-US" sz="2800" dirty="0">
+                <a:latin typeface="Calibri" pitchFamily="34" charset="0"/>
+              </a:rPr>
+              <a:t>). There is a high degree of correlation between bike lane density and crash density. In </a:t>
+            </a:r>
+            <a:r>
+              <a:rPr lang="en-US" sz="2800" b="1" dirty="0">
+                <a:latin typeface="Calibri" pitchFamily="34" charset="0"/>
+              </a:rPr>
+              <a:t>Map 2C</a:t>
+            </a:r>
+            <a:r>
+              <a:rPr lang="en-US" sz="2800" dirty="0">
+                <a:latin typeface="Calibri" pitchFamily="34" charset="0"/>
+              </a:rPr>
+              <a:t>, areas highlighted in purple had more crashes than expected, and those in light green had fewer than expected given this correlation.</a:t>
             </a:r>
           </a:p>
         </p:txBody>
@@ -5413,7 +5471,7 @@
         </p:nvSpPr>
         <p:spPr>
           <a:xfrm>
-            <a:off x="11316666" y="12669072"/>
+            <a:off x="11316666" y="12604466"/>
             <a:ext cx="9692640" cy="685800"/>
           </a:xfrm>
           <a:prstGeom prst="rect">
@@ -5456,7 +5514,7 @@
                   </a:schemeClr>
                 </a:solidFill>
               </a:rPr>
-              <a:t>Additional methods/Results</a:t>
+              <a:t>Results</a:t>
             </a:r>
           </a:p>
         </p:txBody>
@@ -5471,8 +5529,8 @@
         </p:nvSpPr>
         <p:spPr bwMode="auto">
           <a:xfrm>
-            <a:off x="11316666" y="21171501"/>
-            <a:ext cx="9692640" cy="6309373"/>
+            <a:off x="14249401" y="21957980"/>
+            <a:ext cx="6775146" cy="6309373"/>
           </a:xfrm>
           <a:prstGeom prst="rect">
             <a:avLst/>
@@ -5490,7 +5548,7 @@
           <a:effectLst/>
         </p:spPr>
         <p:txBody>
-          <a:bodyPr lIns="137137" tIns="137137" rIns="137137" bIns="137137">
+          <a:bodyPr wrap="square" lIns="137137" tIns="137137" rIns="137137" bIns="137137">
             <a:spAutoFit/>
           </a:bodyPr>
           <a:lstStyle>
@@ -5592,69 +5650,39 @@
             </a:lvl9pPr>
           </a:lstStyle>
           <a:p>
-            <a:pPr eaLnBrk="1" hangingPunct="1"/>
+            <a:pPr marL="457200" indent="-457200" eaLnBrk="1" hangingPunct="1">
+              <a:buFont typeface="Wingdings" pitchFamily="2" charset="2"/>
+              <a:buChar char="§"/>
+            </a:pPr>
             <a:r>
               <a:rPr lang="en-US" sz="2800" dirty="0">
                 <a:latin typeface="Calibri" pitchFamily="34" charset="0"/>
               </a:rPr>
-              <a:t>Click here to insert your Conclusions text. Type it in or copy and paste from your Word document or other source.</a:t>
-            </a:r>
-          </a:p>
-          <a:p>
-            <a:pPr eaLnBrk="1" hangingPunct="1"/>
-            <a:endParaRPr lang="en-US" sz="2800" dirty="0">
-              <a:latin typeface="Calibri" pitchFamily="34" charset="0"/>
-            </a:endParaRPr>
-          </a:p>
-          <a:p>
-            <a:pPr eaLnBrk="1" hangingPunct="1"/>
+              <a:t>Overall, it is likely that there is a cyclical relationship between bike traffic volume, bike lane presence, and crashes. Bike lanes are installed where there are more riders, riders preferentially use those bike lanes, and crashes result as volume increases.</a:t>
+            </a:r>
+          </a:p>
+          <a:p>
+            <a:pPr marL="457200" indent="-457200" eaLnBrk="1" hangingPunct="1">
+              <a:buFont typeface="Wingdings" pitchFamily="2" charset="2"/>
+              <a:buChar char="§"/>
+            </a:pPr>
             <a:r>
               <a:rPr lang="en-US" sz="2800" dirty="0">
                 <a:latin typeface="Calibri" pitchFamily="34" charset="0"/>
               </a:rPr>
-              <a:t>This text box will automatically re-size to your text. To turn off that feature, right click inside this box and go to </a:t>
+              <a:t>Additional interventions beyond bike lanes are likely needed to reduce accidental injury from cycling; focus areas in purple in </a:t>
             </a:r>
             <a:r>
               <a:rPr lang="en-US" sz="2800" b="1" dirty="0">
                 <a:latin typeface="Calibri" pitchFamily="34" charset="0"/>
               </a:rPr>
-              <a:t>Format Shape, Text Box, Autofit</a:t>
+              <a:t>Map 2C </a:t>
             </a:r>
             <a:r>
               <a:rPr lang="en-US" sz="2800" dirty="0">
                 <a:latin typeface="Calibri" pitchFamily="34" charset="0"/>
               </a:rPr>
-              <a:t>, and select the “Do Not Autofit” radio button.</a:t>
-            </a:r>
-          </a:p>
-          <a:p>
-            <a:pPr eaLnBrk="1" hangingPunct="1"/>
-            <a:endParaRPr lang="en-US" sz="2800" dirty="0">
-              <a:latin typeface="Calibri" pitchFamily="34" charset="0"/>
-            </a:endParaRPr>
-          </a:p>
-          <a:p>
-            <a:pPr eaLnBrk="1" hangingPunct="1"/>
-            <a:r>
-              <a:rPr lang="en-US" sz="2800" dirty="0">
-                <a:latin typeface="Calibri" pitchFamily="34" charset="0"/>
-              </a:rPr>
-              <a:t>To change the font style of this text box: Click on the border once to highlight the entire text box, then select a different font or font size that suits you. This text is Calibri 28pt and is easily read up to 4 feet away on a 36x36 poster.</a:t>
-            </a:r>
-          </a:p>
-          <a:p>
-            <a:pPr eaLnBrk="1" hangingPunct="1"/>
-            <a:endParaRPr lang="en-US" sz="2800" dirty="0">
-              <a:latin typeface="Calibri" pitchFamily="34" charset="0"/>
-            </a:endParaRPr>
-          </a:p>
-          <a:p>
-            <a:pPr eaLnBrk="1" hangingPunct="1"/>
-            <a:r>
-              <a:rPr lang="en-US" sz="2800" dirty="0">
-                <a:latin typeface="Calibri" pitchFamily="34" charset="0"/>
-              </a:rPr>
-              <a:t>Zoom out to 100% to preview what this will look like on your printed poster.</a:t>
+              <a:t>should be prioritized. Still, building additional protected and conventional lanes may provide better protection compared to shared lanes.</a:t>
             </a:r>
           </a:p>
         </p:txBody>
@@ -5667,7 +5695,63 @@
         </p:nvSpPr>
         <p:spPr>
           <a:xfrm>
-            <a:off x="11301426" y="20485701"/>
+            <a:off x="14251610" y="21211633"/>
+            <a:ext cx="6757696" cy="746347"/>
+          </a:xfrm>
+          <a:prstGeom prst="rect">
+            <a:avLst/>
+          </a:prstGeom>
+          <a:solidFill>
+            <a:schemeClr val="accent1">
+              <a:lumMod val="75000"/>
+            </a:schemeClr>
+          </a:solidFill>
+          <a:ln w="12700"/>
+        </p:spPr>
+        <p:style>
+          <a:lnRef idx="2">
+            <a:schemeClr val="accent1">
+              <a:shade val="50000"/>
+            </a:schemeClr>
+          </a:lnRef>
+          <a:fillRef idx="1">
+            <a:schemeClr val="accent1"/>
+          </a:fillRef>
+          <a:effectRef idx="0">
+            <a:schemeClr val="accent1"/>
+          </a:effectRef>
+          <a:fontRef idx="minor">
+            <a:schemeClr val="lt1"/>
+          </a:fontRef>
+        </p:style>
+        <p:txBody>
+          <a:bodyPr lIns="68568" tIns="34284" rIns="68568" bIns="34284" rtlCol="0" anchor="ctr"/>
+          <a:lstStyle/>
+          <a:p>
+            <a:pPr algn="ctr"/>
+            <a:r>
+              <a:rPr lang="en-US" sz="4400" b="1" dirty="0">
+                <a:solidFill>
+                  <a:schemeClr val="accent3">
+                    <a:lumMod val="20000"/>
+                    <a:lumOff val="80000"/>
+                  </a:schemeClr>
+                </a:solidFill>
+              </a:rPr>
+              <a:t>Discussion</a:t>
+            </a:r>
+          </a:p>
+        </p:txBody>
+      </p:sp>
+      <p:sp>
+        <p:nvSpPr>
+          <p:cNvPr id="45" name="Rectangle 44"/>
+          <p:cNvSpPr/>
+          <p:nvPr/>
+        </p:nvSpPr>
+        <p:spPr>
+          <a:xfrm>
+            <a:off x="1066543" y="12358518"/>
             <a:ext cx="9692640" cy="685800"/>
           </a:xfrm>
           <a:prstGeom prst="rect">
@@ -5710,62 +5794,6 @@
                   </a:schemeClr>
                 </a:solidFill>
               </a:rPr>
-              <a:t>Discussion/Conclusions</a:t>
-            </a:r>
-          </a:p>
-        </p:txBody>
-      </p:sp>
-      <p:sp>
-        <p:nvSpPr>
-          <p:cNvPr id="45" name="Rectangle 44"/>
-          <p:cNvSpPr/>
-          <p:nvPr/>
-        </p:nvSpPr>
-        <p:spPr>
-          <a:xfrm>
-            <a:off x="11239926" y="4976816"/>
-            <a:ext cx="9692640" cy="685800"/>
-          </a:xfrm>
-          <a:prstGeom prst="rect">
-            <a:avLst/>
-          </a:prstGeom>
-          <a:solidFill>
-            <a:schemeClr val="accent1">
-              <a:lumMod val="75000"/>
-            </a:schemeClr>
-          </a:solidFill>
-          <a:ln w="12700"/>
-        </p:spPr>
-        <p:style>
-          <a:lnRef idx="2">
-            <a:schemeClr val="accent1">
-              <a:shade val="50000"/>
-            </a:schemeClr>
-          </a:lnRef>
-          <a:fillRef idx="1">
-            <a:schemeClr val="accent1"/>
-          </a:fillRef>
-          <a:effectRef idx="0">
-            <a:schemeClr val="accent1"/>
-          </a:effectRef>
-          <a:fontRef idx="minor">
-            <a:schemeClr val="lt1"/>
-          </a:fontRef>
-        </p:style>
-        <p:txBody>
-          <a:bodyPr lIns="68568" tIns="34284" rIns="68568" bIns="34284" rtlCol="0" anchor="ctr"/>
-          <a:lstStyle/>
-          <a:p>
-            <a:pPr algn="ctr"/>
-            <a:r>
-              <a:rPr lang="en-US" sz="4400" b="1" dirty="0">
-                <a:solidFill>
-                  <a:schemeClr val="accent3">
-                    <a:lumMod val="20000"/>
-                    <a:lumOff val="80000"/>
-                  </a:schemeClr>
-                </a:solidFill>
-              </a:rPr>
               <a:t>Methods </a:t>
             </a:r>
           </a:p>
@@ -5781,8 +5809,8 @@
         </p:nvSpPr>
         <p:spPr bwMode="auto">
           <a:xfrm>
-            <a:off x="1423301" y="28099332"/>
-            <a:ext cx="3736641" cy="438569"/>
+            <a:off x="1247655" y="26069730"/>
+            <a:ext cx="9159471" cy="438569"/>
           </a:xfrm>
           <a:prstGeom prst="rect">
             <a:avLst/>
@@ -5929,13 +5957,13 @@
               <a:rPr lang="en-US" sz="2400" b="1" dirty="0">
                 <a:latin typeface="Calibri" pitchFamily="34" charset="0"/>
               </a:rPr>
-              <a:t>Table 1.</a:t>
+              <a:t>Map 2. </a:t>
             </a:r>
             <a:r>
               <a:rPr lang="en-US" sz="2400" dirty="0">
                 <a:latin typeface="Calibri" pitchFamily="34" charset="0"/>
               </a:rPr>
-              <a:t> Label in 24pt Calibri.</a:t>
+              <a:t>Bike Collision and Bike Lane Density By Community District, 2024</a:t>
             </a:r>
           </a:p>
         </p:txBody>
@@ -5950,8 +5978,8 @@
         </p:nvSpPr>
         <p:spPr bwMode="auto">
           <a:xfrm>
-            <a:off x="14324695" y="11722387"/>
-            <a:ext cx="3646103" cy="438569"/>
+            <a:off x="10972800" y="26874845"/>
+            <a:ext cx="1909582" cy="1546565"/>
           </a:xfrm>
           <a:prstGeom prst="rect">
             <a:avLst/>
@@ -5991,7 +6019,7 @@
           </a:extLst>
         </p:spPr>
         <p:txBody>
-          <a:bodyPr wrap="none" lIns="68568" tIns="34284" rIns="68568" bIns="34284">
+          <a:bodyPr wrap="square" lIns="68568" tIns="34284" rIns="68568" bIns="34284">
             <a:spAutoFit/>
           </a:bodyPr>
           <a:lstStyle>
@@ -6093,18 +6121,18 @@
             </a:lvl9pPr>
           </a:lstStyle>
           <a:p>
-            <a:pPr algn="ctr" eaLnBrk="1" hangingPunct="1"/>
+            <a:pPr eaLnBrk="1" hangingPunct="1"/>
             <a:r>
               <a:rPr lang="en-US" sz="2400" b="1" dirty="0">
                 <a:latin typeface="Calibri" pitchFamily="34" charset="0"/>
               </a:rPr>
-              <a:t>Map 1.</a:t>
+              <a:t>Table 1. </a:t>
             </a:r>
             <a:r>
               <a:rPr lang="en-US" sz="2400" dirty="0">
                 <a:latin typeface="Calibri" pitchFamily="34" charset="0"/>
               </a:rPr>
-              <a:t> Label in 24pt Calibri.</a:t>
+              <a:t>Collisions by bike lane type and length</a:t>
             </a:r>
           </a:p>
         </p:txBody>
@@ -6125,8 +6153,8 @@
         </p:nvSpPr>
         <p:spPr bwMode="auto">
           <a:xfrm>
-            <a:off x="1412269" y="25495712"/>
-            <a:ext cx="3736641" cy="438569"/>
+            <a:off x="11270946" y="12153250"/>
+            <a:ext cx="9201534" cy="438569"/>
           </a:xfrm>
           <a:prstGeom prst="rect">
             <a:avLst/>
@@ -6273,13 +6301,13 @@
               <a:rPr lang="en-US" sz="2400" b="1" dirty="0">
                 <a:latin typeface="Calibri" pitchFamily="34" charset="0"/>
               </a:rPr>
-              <a:t>Table 1.</a:t>
+              <a:t>Map 1.</a:t>
             </a:r>
             <a:r>
               <a:rPr lang="en-US" sz="2400" dirty="0">
                 <a:latin typeface="Calibri" pitchFamily="34" charset="0"/>
               </a:rPr>
-              <a:t> Label in 24pt Calibri.</a:t>
+              <a:t> Bike lane type distribution and total length by community district</a:t>
             </a:r>
           </a:p>
         </p:txBody>
@@ -6299,14 +6327,14 @@
           <p:nvPr>
             <p:extLst>
               <p:ext uri="{D42A27DB-BD31-4B8C-83A1-F6EECF244321}">
-                <p14:modId xmlns:p14="http://schemas.microsoft.com/office/powerpoint/2010/main" val="292990765"/>
+                <p14:modId xmlns:p14="http://schemas.microsoft.com/office/powerpoint/2010/main" val="474856275"/>
               </p:ext>
             </p:extLst>
           </p:nvPr>
         </p:nvGraphicFramePr>
         <p:xfrm>
-          <a:off x="1423301" y="26099818"/>
-          <a:ext cx="5891898" cy="1866900"/>
+          <a:off x="1247785" y="26816413"/>
+          <a:ext cx="9549498" cy="1604997"/>
         </p:xfrm>
         <a:graphic>
           <a:graphicData uri="http://schemas.openxmlformats.org/drawingml/2006/table">
@@ -6315,28 +6343,28 @@
                 <a:tableStyleId>{6E25E649-3F16-4E02-A733-19D2CDBF48F0}</a:tableStyleId>
               </a:tblPr>
               <a:tblGrid>
-                <a:gridCol w="1790555">
+                <a:gridCol w="2005699">
                   <a:extLst>
                     <a:ext uri="{9D8B030D-6E8A-4147-A177-3AD203B41FA5}">
                       <a16:colId xmlns:a16="http://schemas.microsoft.com/office/drawing/2014/main" val="618651207"/>
                     </a:ext>
                   </a:extLst>
                 </a:gridCol>
-                <a:gridCol w="1510544">
+                <a:gridCol w="2895600">
                   <a:extLst>
                     <a:ext uri="{9D8B030D-6E8A-4147-A177-3AD203B41FA5}">
                       <a16:colId xmlns:a16="http://schemas.microsoft.com/office/drawing/2014/main" val="1064282208"/>
                     </a:ext>
                   </a:extLst>
                 </a:gridCol>
-                <a:gridCol w="990600">
+                <a:gridCol w="2054621">
                   <a:extLst>
                     <a:ext uri="{9D8B030D-6E8A-4147-A177-3AD203B41FA5}">
                       <a16:colId xmlns:a16="http://schemas.microsoft.com/office/drawing/2014/main" val="1618239273"/>
                     </a:ext>
                   </a:extLst>
                 </a:gridCol>
-                <a:gridCol w="1600199">
+                <a:gridCol w="2593578">
                   <a:extLst>
                     <a:ext uri="{9D8B030D-6E8A-4147-A177-3AD203B41FA5}">
                       <a16:colId xmlns:a16="http://schemas.microsoft.com/office/drawing/2014/main" val="3829869367"/>
@@ -6344,7 +6372,7 @@
                   </a:extLst>
                 </a:gridCol>
               </a:tblGrid>
-              <a:tr h="731871">
+              <a:tr h="479142">
                 <a:tc>
                   <a:txBody>
                     <a:bodyPr/>
@@ -6421,12 +6449,12 @@
                         <a:buNone/>
                       </a:pPr>
                       <a:r>
-                        <a:rPr lang="en-US" sz="2400" u="none" strike="noStrike">
+                        <a:rPr lang="en-US" sz="2400" u="none" strike="noStrike" dirty="0">
                           <a:effectLst/>
                         </a:rPr>
                         <a:t>Number of Collisions</a:t>
                       </a:r>
-                      <a:endParaRPr lang="en-US" sz="2400" b="1" i="0" u="none" strike="noStrike">
+                      <a:endParaRPr lang="en-US" sz="2400" b="1" i="0" u="none" strike="noStrike" dirty="0">
                         <a:solidFill>
                           <a:srgbClr val="000000"/>
                         </a:solidFill>
@@ -7403,7 +7431,7 @@
           <p:nvPr/>
         </p:nvPicPr>
         <p:blipFill>
-          <a:blip r:embed="rId2">
+          <a:blip r:embed="rId9">
             <a:extLst>
               <a:ext uri="{28A0092B-C50C-407E-A947-70E740481C1C}">
                 <a14:useLocalDpi xmlns:a14="http://schemas.microsoft.com/office/drawing/2010/main" val="0"/>
@@ -7417,80 +7445,8 @@
         </p:blipFill>
         <p:spPr>
           <a:xfrm>
-            <a:off x="1293540" y="9001646"/>
-            <a:ext cx="9679260" cy="10210800"/>
-          </a:xfrm>
-          <a:prstGeom prst="rect">
-            <a:avLst/>
-          </a:prstGeom>
-        </p:spPr>
-      </p:pic>
-      <p:pic>
-        <p:nvPicPr>
-          <p:cNvPr id="8" name="Picture 7" descr="A graph showing a number of lanes&#10;&#10;AI-generated content may be incorrect.">
-            <a:extLst>
-              <a:ext uri="{FF2B5EF4-FFF2-40B4-BE49-F238E27FC236}">
-                <a16:creationId xmlns:a16="http://schemas.microsoft.com/office/drawing/2014/main" id="{1FEAA516-6BF9-E546-FC05-317B2015DB59}"/>
-              </a:ext>
-            </a:extLst>
-          </p:cNvPr>
-          <p:cNvPicPr>
-            <a:picLocks noChangeAspect="1"/>
-          </p:cNvPicPr>
-          <p:nvPr/>
-        </p:nvPicPr>
-        <p:blipFill>
-          <a:blip r:embed="rId3">
-            <a:extLst>
-              <a:ext uri="{28A0092B-C50C-407E-A947-70E740481C1C}">
-                <a14:useLocalDpi xmlns:a14="http://schemas.microsoft.com/office/drawing/2010/main" val="0"/>
-              </a:ext>
-            </a:extLst>
-          </a:blip>
-          <a:stretch>
-            <a:fillRect/>
-          </a:stretch>
-        </p:blipFill>
-        <p:spPr>
-          <a:xfrm>
-            <a:off x="1140824" y="18218474"/>
-            <a:ext cx="10599631" cy="7419742"/>
-          </a:xfrm>
-          <a:prstGeom prst="rect">
-            <a:avLst/>
-          </a:prstGeom>
-        </p:spPr>
-      </p:pic>
-      <p:pic>
-        <p:nvPicPr>
-          <p:cNvPr id="11" name="Picture 10" descr="A map of the united kingdom&#10;&#10;AI-generated content may be incorrect.">
-            <a:extLst>
-              <a:ext uri="{FF2B5EF4-FFF2-40B4-BE49-F238E27FC236}">
-                <a16:creationId xmlns:a16="http://schemas.microsoft.com/office/drawing/2014/main" id="{B66B0A67-6369-AF30-7ACC-BB407ED047DB}"/>
-              </a:ext>
-            </a:extLst>
-          </p:cNvPr>
-          <p:cNvPicPr>
-            <a:picLocks noChangeAspect="1"/>
-          </p:cNvPicPr>
-          <p:nvPr/>
-        </p:nvPicPr>
-        <p:blipFill>
-          <a:blip r:embed="rId4">
-            <a:extLst>
-              <a:ext uri="{28A0092B-C50C-407E-A947-70E740481C1C}">
-                <a14:useLocalDpi xmlns:a14="http://schemas.microsoft.com/office/drawing/2010/main" val="0"/>
-              </a:ext>
-            </a:extLst>
-          </a:blip>
-          <a:stretch>
-            <a:fillRect/>
-          </a:stretch>
-        </p:blipFill>
-        <p:spPr>
-          <a:xfrm>
-            <a:off x="11245481" y="9841117"/>
-            <a:ext cx="9394491" cy="9394491"/>
+            <a:off x="12115800" y="4114800"/>
+            <a:ext cx="7670111" cy="8091318"/>
           </a:xfrm>
           <a:prstGeom prst="rect">
             <a:avLst/>

</xml_diff>

<commit_message>
fixing some plot labeling
</commit_message>
<xml_diff>
--- a/bike_nyc_gis.pptx
+++ b/bike_nyc_gis.pptx
@@ -4142,10 +4142,10 @@
       </p:grpSpPr>
       <p:pic>
         <p:nvPicPr>
-          <p:cNvPr id="19" name="Picture 18" descr="A map of the united states&#10;&#10;AI-generated content may be incorrect.">
+          <p:cNvPr id="6" name="Picture 5" descr="A map of different states&#10;&#10;AI-generated content may be incorrect.">
             <a:extLst>
               <a:ext uri="{FF2B5EF4-FFF2-40B4-BE49-F238E27FC236}">
-                <a16:creationId xmlns:a16="http://schemas.microsoft.com/office/drawing/2014/main" id="{1A71817A-50AC-0C47-79D8-BAD26C48C26E}"/>
+                <a16:creationId xmlns:a16="http://schemas.microsoft.com/office/drawing/2014/main" id="{03DF0510-4C81-9A7E-D780-CEA1CB6BC050}"/>
               </a:ext>
             </a:extLst>
           </p:cNvPr>
@@ -4168,8 +4168,45 @@
         </p:blipFill>
         <p:spPr>
           <a:xfrm>
-            <a:off x="1066543" y="21539455"/>
-            <a:ext cx="13563857" cy="4521286"/>
+            <a:off x="662634" y="21379579"/>
+            <a:ext cx="13897407" cy="4632469"/>
+          </a:xfrm>
+          <a:prstGeom prst="rect">
+            <a:avLst/>
+          </a:prstGeom>
+        </p:spPr>
+      </p:pic>
+      <p:pic>
+        <p:nvPicPr>
+          <p:cNvPr id="23" name="Picture 22" descr="A map of a city with different colored circles&#10;&#10;AI-generated content may be incorrect.">
+            <a:extLst>
+              <a:ext uri="{FF2B5EF4-FFF2-40B4-BE49-F238E27FC236}">
+                <a16:creationId xmlns:a16="http://schemas.microsoft.com/office/drawing/2014/main" id="{2D1421E0-CF88-CEE0-57D3-6EA5F2AF4EC6}"/>
+              </a:ext>
+            </a:extLst>
+          </p:cNvPr>
+          <p:cNvPicPr>
+            <a:picLocks noChangeAspect="1"/>
+          </p:cNvPicPr>
+          <p:nvPr/>
+        </p:nvPicPr>
+        <p:blipFill>
+          <a:blip r:embed="rId3">
+            <a:extLst>
+              <a:ext uri="{28A0092B-C50C-407E-A947-70E740481C1C}">
+                <a14:useLocalDpi xmlns:a14="http://schemas.microsoft.com/office/drawing/2010/main" val="0"/>
+              </a:ext>
+            </a:extLst>
+          </a:blip>
+          <a:srcRect t="4981" b="7110"/>
+          <a:stretch>
+            <a:fillRect/>
+          </a:stretch>
+        </p:blipFill>
+        <p:spPr>
+          <a:xfrm>
+            <a:off x="12478276" y="4150694"/>
+            <a:ext cx="7627835" cy="8046720"/>
           </a:xfrm>
           <a:prstGeom prst="rect">
             <a:avLst/>
@@ -4651,7 +4688,7 @@
             </a:r>
             <a:r>
               <a:rPr lang="en-US" sz="1400" dirty="0">
-                <a:hlinkClick r:id="rId3"/>
+                <a:hlinkClick r:id="rId4"/>
               </a:rPr>
               <a:t>10.3390/safety2040026</a:t>
             </a:r>
@@ -4684,7 +4721,7 @@
             </a:r>
             <a:r>
               <a:rPr lang="en-US" sz="1400" dirty="0">
-                <a:hlinkClick r:id="rId4"/>
+                <a:hlinkClick r:id="rId5"/>
               </a:rPr>
               <a:t>10.1016/j.jth.2023.101669</a:t>
             </a:r>
@@ -4709,7 +4746,7 @@
             </a:r>
             <a:r>
               <a:rPr lang="en-US" sz="1400" dirty="0">
-                <a:hlinkClick r:id="rId5"/>
+                <a:hlinkClick r:id="rId6"/>
               </a:rPr>
               <a:t>10.2105/AJPH.2011.300319</a:t>
             </a:r>
@@ -4726,7 +4763,7 @@
             </a:r>
             <a:r>
               <a:rPr lang="en-US" sz="1400" u="sng" dirty="0">
-                <a:hlinkClick r:id="rId6"/>
+                <a:hlinkClick r:id="rId7"/>
               </a:rPr>
               <a:t>https://data.cityofnewyork.us/City-Government/Community-Districts/5crt-au7u/about_data</a:t>
             </a:r>
@@ -4743,7 +4780,7 @@
             </a:r>
             <a:r>
               <a:rPr lang="en-US" sz="1400" u="sng" dirty="0">
-                <a:hlinkClick r:id="rId7"/>
+                <a:hlinkClick r:id="rId8"/>
               </a:rPr>
               <a:t>https://data.cityofnewyork.us/Public-Safety/Motor-Vehicle-Collisions-Crashes/h9gi-nx95/about_data</a:t>
             </a:r>
@@ -4760,7 +4797,7 @@
             </a:r>
             <a:r>
               <a:rPr lang="en-US" sz="1400" u="sng" dirty="0">
-                <a:hlinkClick r:id="rId8"/>
+                <a:hlinkClick r:id="rId9"/>
               </a:rPr>
               <a:t>https://data.cityofnewyork.us/dataset/New-York-City-Bike-Routes/mzxg-pwib/about_data</a:t>
             </a:r>
@@ -4817,8 +4854,8 @@
         </p:nvSpPr>
         <p:spPr bwMode="auto">
           <a:xfrm>
-            <a:off x="1104643" y="5037643"/>
-            <a:ext cx="9692640" cy="7171147"/>
+            <a:off x="640275" y="5037643"/>
+            <a:ext cx="10157008" cy="7171147"/>
           </a:xfrm>
           <a:prstGeom prst="rect">
             <a:avLst/>
@@ -4836,7 +4873,7 @@
           <a:effectLst/>
         </p:spPr>
         <p:txBody>
-          <a:bodyPr lIns="137137" tIns="137137" rIns="137137" bIns="137137">
+          <a:bodyPr wrap="square" lIns="137137" tIns="137137" rIns="137137" bIns="137137">
             <a:spAutoFit/>
           </a:bodyPr>
           <a:lstStyle>
@@ -4983,8 +5020,8 @@
         </p:nvSpPr>
         <p:spPr>
           <a:xfrm>
-            <a:off x="1104643" y="4378828"/>
-            <a:ext cx="9692640" cy="685800"/>
+            <a:off x="640275" y="4378828"/>
+            <a:ext cx="10157008" cy="685800"/>
           </a:xfrm>
           <a:prstGeom prst="rect">
             <a:avLst/>
@@ -5041,8 +5078,8 @@
         </p:nvSpPr>
         <p:spPr bwMode="auto">
           <a:xfrm>
-            <a:off x="1059561" y="12894855"/>
-            <a:ext cx="9692640" cy="8032922"/>
+            <a:off x="631415" y="12894855"/>
+            <a:ext cx="10165867" cy="7602035"/>
           </a:xfrm>
           <a:prstGeom prst="rect">
             <a:avLst/>
@@ -5060,7 +5097,7 @@
           <a:effectLst/>
         </p:spPr>
         <p:txBody>
-          <a:bodyPr lIns="137137" tIns="137137" rIns="137137" bIns="137137">
+          <a:bodyPr wrap="square" lIns="137137" tIns="137137" rIns="137137" bIns="137137">
             <a:spAutoFit/>
           </a:bodyPr>
           <a:lstStyle>
@@ -5245,8 +5282,8 @@
         </p:nvSpPr>
         <p:spPr bwMode="auto">
           <a:xfrm>
-            <a:off x="11316666" y="13276765"/>
-            <a:ext cx="9692640" cy="7602035"/>
+            <a:off x="11316665" y="13276765"/>
+            <a:ext cx="9951059" cy="7602035"/>
           </a:xfrm>
           <a:prstGeom prst="rect">
             <a:avLst/>
@@ -5264,7 +5301,7 @@
           <a:effectLst/>
         </p:spPr>
         <p:txBody>
-          <a:bodyPr lIns="137137" tIns="137137" rIns="137137" bIns="137137">
+          <a:bodyPr wrap="square" lIns="137137" tIns="137137" rIns="137137" bIns="137137">
             <a:spAutoFit/>
           </a:bodyPr>
           <a:lstStyle>
@@ -5471,8 +5508,8 @@
         </p:nvSpPr>
         <p:spPr>
           <a:xfrm>
-            <a:off x="11316666" y="12604466"/>
-            <a:ext cx="9692640" cy="685800"/>
+            <a:off x="11316665" y="12604466"/>
+            <a:ext cx="9951059" cy="685800"/>
           </a:xfrm>
           <a:prstGeom prst="rect">
             <a:avLst/>
@@ -5529,8 +5566,8 @@
         </p:nvSpPr>
         <p:spPr bwMode="auto">
           <a:xfrm>
-            <a:off x="14249401" y="21957980"/>
-            <a:ext cx="6775146" cy="6309373"/>
+            <a:off x="13993243" y="21834740"/>
+            <a:ext cx="7289723" cy="6740260"/>
           </a:xfrm>
           <a:prstGeom prst="rect">
             <a:avLst/>
@@ -5658,7 +5695,7 @@
               <a:rPr lang="en-US" sz="2800" dirty="0">
                 <a:latin typeface="Calibri" pitchFamily="34" charset="0"/>
               </a:rPr>
-              <a:t>Overall, it is likely that there is a cyclical relationship between bike traffic volume, bike lane presence, and crashes. Bike lanes are installed where there are more riders, riders preferentially use those bike lanes, and crashes result as volume increases.</a:t>
+              <a:t>Overall, it is likely that there is a cyclical relationship between bike traffic volume, bike lane presence, and crashes. Bike lanes are installed where there are more riders, riders preferentially use those bike lanes, and crashes result as volume increases. The lack of comprehensive bike traffic data is a major limitation of this analysis. </a:t>
             </a:r>
           </a:p>
           <a:p>
@@ -5695,8 +5732,8 @@
         </p:nvSpPr>
         <p:spPr>
           <a:xfrm>
-            <a:off x="14251610" y="21211633"/>
-            <a:ext cx="6757696" cy="746347"/>
+            <a:off x="13993243" y="21088393"/>
+            <a:ext cx="7289722" cy="746347"/>
           </a:xfrm>
           <a:prstGeom prst="rect">
             <a:avLst/>
@@ -5751,8 +5788,8 @@
         </p:nvSpPr>
         <p:spPr>
           <a:xfrm>
-            <a:off x="1066543" y="12358518"/>
-            <a:ext cx="9692640" cy="685800"/>
+            <a:off x="631415" y="12358518"/>
+            <a:ext cx="10165867" cy="685800"/>
           </a:xfrm>
           <a:prstGeom prst="rect">
             <a:avLst/>
@@ -5809,7 +5846,7 @@
         </p:nvSpPr>
         <p:spPr bwMode="auto">
           <a:xfrm>
-            <a:off x="1247655" y="26069730"/>
+            <a:off x="838201" y="26037285"/>
             <a:ext cx="9159471" cy="438569"/>
           </a:xfrm>
           <a:prstGeom prst="rect">
@@ -6327,13 +6364,13 @@
           <p:nvPr>
             <p:extLst>
               <p:ext uri="{D42A27DB-BD31-4B8C-83A1-F6EECF244321}">
-                <p14:modId xmlns:p14="http://schemas.microsoft.com/office/powerpoint/2010/main" val="474856275"/>
+                <p14:modId xmlns:p14="http://schemas.microsoft.com/office/powerpoint/2010/main" val="287932675"/>
               </p:ext>
             </p:extLst>
           </p:nvPr>
         </p:nvGraphicFramePr>
         <p:xfrm>
-          <a:off x="1247785" y="26816413"/>
+          <a:off x="1202703" y="26839746"/>
           <a:ext cx="9549498" cy="1604997"/>
         </p:xfrm>
         <a:graphic>
@@ -6657,12 +6694,12 @@
                         <a:buNone/>
                       </a:pPr>
                       <a:r>
-                        <a:rPr lang="en-US" sz="2400" u="none" strike="noStrike">
+                        <a:rPr lang="en-US" sz="2400" u="none" strike="noStrike" dirty="0">
                           <a:effectLst/>
                         </a:rPr>
                         <a:t>Protected</a:t>
                       </a:r>
-                      <a:endParaRPr lang="en-US" sz="2400" b="0" i="0" u="none" strike="noStrike">
+                      <a:endParaRPr lang="en-US" sz="2400" b="0" i="0" u="none" strike="noStrike" dirty="0">
                         <a:solidFill>
                           <a:srgbClr val="000000"/>
                         </a:solidFill>
@@ -7416,43 +7453,6 @@
           </a:graphicData>
         </a:graphic>
       </p:graphicFrame>
-      <p:pic>
-        <p:nvPicPr>
-          <p:cNvPr id="23" name="Picture 22" descr="A map of a city with different colored circles&#10;&#10;AI-generated content may be incorrect.">
-            <a:extLst>
-              <a:ext uri="{FF2B5EF4-FFF2-40B4-BE49-F238E27FC236}">
-                <a16:creationId xmlns:a16="http://schemas.microsoft.com/office/drawing/2014/main" id="{2D1421E0-CF88-CEE0-57D3-6EA5F2AF4EC6}"/>
-              </a:ext>
-            </a:extLst>
-          </p:cNvPr>
-          <p:cNvPicPr>
-            <a:picLocks noChangeAspect="1"/>
-          </p:cNvPicPr>
-          <p:nvPr/>
-        </p:nvPicPr>
-        <p:blipFill>
-          <a:blip r:embed="rId9">
-            <a:extLst>
-              <a:ext uri="{28A0092B-C50C-407E-A947-70E740481C1C}">
-                <a14:useLocalDpi xmlns:a14="http://schemas.microsoft.com/office/drawing/2010/main" val="0"/>
-              </a:ext>
-            </a:extLst>
-          </a:blip>
-          <a:srcRect t="4981" b="7110"/>
-          <a:stretch>
-            <a:fillRect/>
-          </a:stretch>
-        </p:blipFill>
-        <p:spPr>
-          <a:xfrm>
-            <a:off x="12115800" y="4114800"/>
-            <a:ext cx="7670111" cy="8091318"/>
-          </a:xfrm>
-          <a:prstGeom prst="rect">
-            <a:avLst/>
-          </a:prstGeom>
-        </p:spPr>
-      </p:pic>
     </p:spTree>
     <p:extLst>
       <p:ext uri="{BB962C8B-B14F-4D97-AF65-F5344CB8AC3E}">

</xml_diff>